<commit_message>
multilingual changes - recent
</commit_message>
<xml_diff>
--- a/scripts/test_en.pptx
+++ b/scripts/test_en.pptx
@@ -13093,16 +13093,13 @@
           <a:lstStyle/>
           <a:p>
             <a:pPr algn="ctr">
-              <a:defRPr sz="5400" b="1">
+              <a:defRPr sz="5400">
                 <a:solidFill>
                   <a:srgbClr val="C0392B"/>
                 </a:solidFill>
-                <a:latin typeface="Segoe UI Semibold"/>
+                <a:latin typeface="Calibri"/>
               </a:defRPr>
             </a:pPr>
-            <a:r>
-              <a:t>Sales Pitch Deck</a:t>
-            </a:r>
           </a:p>
         </p:txBody>
       </p:sp>
@@ -13268,8 +13265,8 @@
         </p:blipFill>
         <p:spPr>
           <a:xfrm>
-            <a:off x="4105656" y="3840480"/>
-            <a:ext cx="3977639" cy="2651759"/>
+            <a:off x="2286000" y="4114800"/>
+            <a:ext cx="3657600" cy="2438400"/>
           </a:xfrm>
           <a:prstGeom prst="rect">
             <a:avLst/>

</xml_diff>